<commit_message>
added hw01, minor edit to lec01 jupyter PPT
</commit_message>
<xml_diff>
--- a/LEC/lec01-course-overview-jupyter/IS_Class1__JupyterNotebook.pptx
+++ b/LEC/lec01-course-overview-jupyter/IS_Class1__JupyterNotebook.pptx
@@ -139,7 +139,7 @@
 <file path=ppt/revisionInfo.xml><?xml version="1.0" encoding="utf-8"?>
 <p1510:revInfo xmlns:a="http://schemas.openxmlformats.org/drawingml/2006/main" xmlns:r="http://schemas.openxmlformats.org/officeDocument/2006/relationships" xmlns:p1510="http://schemas.microsoft.com/office/powerpoint/2015/10/main">
   <p1510:revLst>
-    <p1510:client id="{B11FBF9F-35BD-4249-9BE5-5F495AAEEB1A}" v="1" dt="2026-08-24T17:19:16.111"/>
+    <p1510:client id="{B11FBF9F-35BD-4249-9BE5-5F495AAEEB1A}" v="11" dt="2026-08-25T12:59:05.545"/>
   </p1510:revLst>
 </p1510:revInfo>
 </file>
@@ -148,23 +148,31 @@
 <pc:chgInfo xmlns:a="http://schemas.openxmlformats.org/drawingml/2006/main" xmlns:r="http://schemas.openxmlformats.org/officeDocument/2006/relationships" xmlns:ac="http://schemas.microsoft.com/office/drawing/2013/main/command" xmlns:pc="http://schemas.microsoft.com/office/powerpoint/2013/main/command">
   <pc:docChgLst>
     <pc:chgData name="Frommer, Ian Dr. (EDU)" userId="28ca3ff0-544f-450a-928b-99e19cf49b89" providerId="ADAL" clId="{A3E8E5B1-0D91-4643-B70B-3D065C8674E0}"/>
-    <pc:docChg chg="custSel modSld">
-      <pc:chgData name="Frommer, Ian Dr. (EDU)" userId="28ca3ff0-544f-450a-928b-99e19cf49b89" providerId="ADAL" clId="{A3E8E5B1-0D91-4643-B70B-3D065C8674E0}" dt="2026-08-24T17:20:49.350" v="131" actId="1076"/>
+    <pc:docChg chg="undo custSel modSld">
+      <pc:chgData name="Frommer, Ian Dr. (EDU)" userId="28ca3ff0-544f-450a-928b-99e19cf49b89" providerId="ADAL" clId="{A3E8E5B1-0D91-4643-B70B-3D065C8674E0}" dt="2026-08-25T12:59:33.164" v="223"/>
       <pc:docMkLst>
         <pc:docMk/>
       </pc:docMkLst>
-      <pc:sldChg chg="addSp modSp mod">
-        <pc:chgData name="Frommer, Ian Dr. (EDU)" userId="28ca3ff0-544f-450a-928b-99e19cf49b89" providerId="ADAL" clId="{A3E8E5B1-0D91-4643-B70B-3D065C8674E0}" dt="2026-08-24T17:20:49.350" v="131" actId="1076"/>
+      <pc:sldChg chg="addSp delSp modSp mod">
+        <pc:chgData name="Frommer, Ian Dr. (EDU)" userId="28ca3ff0-544f-450a-928b-99e19cf49b89" providerId="ADAL" clId="{A3E8E5B1-0D91-4643-B70B-3D065C8674E0}" dt="2026-08-25T12:59:33.164" v="223"/>
         <pc:sldMkLst>
           <pc:docMk/>
           <pc:sldMk cId="4040525063" sldId="281"/>
         </pc:sldMkLst>
-        <pc:spChg chg="add mod">
-          <ac:chgData name="Frommer, Ian Dr. (EDU)" userId="28ca3ff0-544f-450a-928b-99e19cf49b89" providerId="ADAL" clId="{A3E8E5B1-0D91-4643-B70B-3D065C8674E0}" dt="2026-08-24T17:20:49.350" v="131" actId="1076"/>
+        <pc:spChg chg="add del mod">
+          <ac:chgData name="Frommer, Ian Dr. (EDU)" userId="28ca3ff0-544f-450a-928b-99e19cf49b89" providerId="ADAL" clId="{A3E8E5B1-0D91-4643-B70B-3D065C8674E0}" dt="2026-08-25T12:59:33.164" v="223"/>
           <ac:spMkLst>
             <pc:docMk/>
             <pc:sldMk cId="4040525063" sldId="281"/>
             <ac:spMk id="4" creationId="{34186068-3291-DBBB-E851-33E36945791F}"/>
+          </ac:spMkLst>
+        </pc:spChg>
+        <pc:spChg chg="mod">
+          <ac:chgData name="Frommer, Ian Dr. (EDU)" userId="28ca3ff0-544f-450a-928b-99e19cf49b89" providerId="ADAL" clId="{A3E8E5B1-0D91-4643-B70B-3D065C8674E0}" dt="2026-08-25T12:59:31.889" v="221" actId="403"/>
+          <ac:spMkLst>
+            <pc:docMk/>
+            <pc:sldMk cId="4040525063" sldId="281"/>
+            <ac:spMk id="9" creationId="{00000000-0000-0000-0000-000000000000}"/>
           </ac:spMkLst>
         </pc:spChg>
       </pc:sldChg>
@@ -278,7 +286,7 @@
           <a:p>
             <a:fld id="{AD26BD79-8CCC-4D1D-9135-5F2DDDC9A65B}" type="datetimeFigureOut">
               <a:rPr lang="en-US" smtClean="0"/>
-              <a:t>8/24/2026</a:t>
+              <a:t>8/25/2026</a:t>
             </a:fld>
             <a:endParaRPr lang="en-US"/>
           </a:p>
@@ -443,7 +451,7 @@
           <a:p>
             <a:fld id="{A309E764-6B51-3647-AA90-23DDC6992D76}" type="datetimeFigureOut">
               <a:rPr lang="en-US" smtClean="0"/>
-              <a:t>8/24/2026</a:t>
+              <a:t>8/25/2026</a:t>
             </a:fld>
             <a:endParaRPr lang="en-US"/>
           </a:p>
@@ -1098,7 +1106,7 @@
           <a:p>
             <a:fld id="{085A468E-2C0E-5A40-ACD7-4640A10B25AE}" type="datetimeFigureOut">
               <a:rPr lang="en-US" smtClean="0"/>
-              <a:t>8/24/2026</a:t>
+              <a:t>8/25/2026</a:t>
             </a:fld>
             <a:endParaRPr lang="en-US"/>
           </a:p>
@@ -1296,7 +1304,7 @@
           <a:p>
             <a:fld id="{085A468E-2C0E-5A40-ACD7-4640A10B25AE}" type="datetimeFigureOut">
               <a:rPr lang="en-US" smtClean="0"/>
-              <a:t>8/24/2026</a:t>
+              <a:t>8/25/2026</a:t>
             </a:fld>
             <a:endParaRPr lang="en-US"/>
           </a:p>
@@ -1471,7 +1479,7 @@
           <a:p>
             <a:fld id="{085A468E-2C0E-5A40-ACD7-4640A10B25AE}" type="datetimeFigureOut">
               <a:rPr lang="en-US" smtClean="0"/>
-              <a:t>8/24/2026</a:t>
+              <a:t>8/25/2026</a:t>
             </a:fld>
             <a:endParaRPr lang="en-US"/>
           </a:p>
@@ -1634,7 +1642,7 @@
           <a:p>
             <a:fld id="{085A468E-2C0E-5A40-ACD7-4640A10B25AE}" type="datetimeFigureOut">
               <a:rPr lang="en-US" smtClean="0"/>
-              <a:t>8/24/2026</a:t>
+              <a:t>8/25/2026</a:t>
             </a:fld>
             <a:endParaRPr lang="en-US"/>
           </a:p>
@@ -1882,7 +1890,7 @@
           <a:p>
             <a:fld id="{085A468E-2C0E-5A40-ACD7-4640A10B25AE}" type="datetimeFigureOut">
               <a:rPr lang="en-US" smtClean="0"/>
-              <a:t>8/24/2026</a:t>
+              <a:t>8/25/2026</a:t>
             </a:fld>
             <a:endParaRPr lang="en-US"/>
           </a:p>
@@ -2199,7 +2207,7 @@
           <a:p>
             <a:fld id="{085A468E-2C0E-5A40-ACD7-4640A10B25AE}" type="datetimeFigureOut">
               <a:rPr lang="en-US" smtClean="0"/>
-              <a:t>8/24/2026</a:t>
+              <a:t>8/25/2026</a:t>
             </a:fld>
             <a:endParaRPr lang="en-US"/>
           </a:p>
@@ -2665,7 +2673,7 @@
           <a:p>
             <a:fld id="{085A468E-2C0E-5A40-ACD7-4640A10B25AE}" type="datetimeFigureOut">
               <a:rPr lang="en-US" smtClean="0"/>
-              <a:t>8/24/2026</a:t>
+              <a:t>8/25/2026</a:t>
             </a:fld>
             <a:endParaRPr lang="en-US"/>
           </a:p>
@@ -2812,7 +2820,7 @@
           <a:p>
             <a:fld id="{085A468E-2C0E-5A40-ACD7-4640A10B25AE}" type="datetimeFigureOut">
               <a:rPr lang="en-US" smtClean="0"/>
-              <a:t>8/24/2026</a:t>
+              <a:t>8/25/2026</a:t>
             </a:fld>
             <a:endParaRPr lang="en-US"/>
           </a:p>
@@ -2902,7 +2910,7 @@
           <a:p>
             <a:fld id="{085A468E-2C0E-5A40-ACD7-4640A10B25AE}" type="datetimeFigureOut">
               <a:rPr lang="en-US" smtClean="0"/>
-              <a:t>8/24/2026</a:t>
+              <a:t>8/25/2026</a:t>
             </a:fld>
             <a:endParaRPr lang="en-US"/>
           </a:p>
@@ -3176,7 +3184,7 @@
           <a:p>
             <a:fld id="{085A468E-2C0E-5A40-ACD7-4640A10B25AE}" type="datetimeFigureOut">
               <a:rPr lang="en-US" smtClean="0"/>
-              <a:t>8/24/2026</a:t>
+              <a:t>8/25/2026</a:t>
             </a:fld>
             <a:endParaRPr lang="en-US"/>
           </a:p>
@@ -3481,7 +3489,7 @@
           <a:p>
             <a:fld id="{085A468E-2C0E-5A40-ACD7-4640A10B25AE}" type="datetimeFigureOut">
               <a:rPr lang="en-US" smtClean="0"/>
-              <a:t>8/24/2026</a:t>
+              <a:t>8/25/2026</a:t>
             </a:fld>
             <a:endParaRPr lang="en-US"/>
           </a:p>
@@ -3779,7 +3787,7 @@
           <a:p>
             <a:fld id="{085A468E-2C0E-5A40-ACD7-4640A10B25AE}" type="datetimeFigureOut">
               <a:rPr lang="en-US" smtClean="0"/>
-              <a:t>8/24/2026</a:t>
+              <a:t>8/25/2026</a:t>
             </a:fld>
             <a:endParaRPr lang="en-US"/>
           </a:p>
@@ -4281,9 +4289,6 @@
             </a:r>
           </a:p>
           <a:p>
-            <a:endParaRPr lang="en-US" sz="2800" b="1" dirty="0"/>
-          </a:p>
-          <a:p>
             <a:pPr lvl="1"/>
             <a:r>
               <a:rPr lang="en-US" sz="2400" dirty="0"/>
@@ -4292,7 +4297,7 @@
           </a:p>
           <a:p>
             <a:pPr lvl="1"/>
-            <a:endParaRPr lang="en-US" sz="2400" dirty="0"/>
+            <a:endParaRPr lang="en-US" sz="1200" dirty="0"/>
           </a:p>
           <a:p>
             <a:pPr lvl="1"/>
@@ -4309,68 +4314,49 @@
             </a:r>
           </a:p>
           <a:p>
-            <a:pPr lvl="1"/>
-            <a:endParaRPr lang="en-US" sz="2400" dirty="0">
-              <a:hlinkClick r:id="rId3"/>
-            </a:endParaRPr>
-          </a:p>
-          <a:p>
-            <a:pPr lvl="1"/>
-            <a:endParaRPr lang="en-US" sz="2400" dirty="0"/>
-          </a:p>
-        </p:txBody>
-      </p:sp>
-      <p:sp>
-        <p:nvSpPr>
-          <p:cNvPr id="4" name="TextBox 3">
-            <a:extLst>
-              <a:ext uri="{FF2B5EF4-FFF2-40B4-BE49-F238E27FC236}">
-                <a16:creationId xmlns:a16="http://schemas.microsoft.com/office/drawing/2014/main" id="{34186068-3291-DBBB-E851-33E36945791F}"/>
-              </a:ext>
-            </a:extLst>
-          </p:cNvPr>
-          <p:cNvSpPr txBox="1"/>
-          <p:nvPr/>
-        </p:nvSpPr>
-        <p:spPr>
-          <a:xfrm>
-            <a:off x="1863306" y="5749036"/>
-            <a:ext cx="4572000" cy="923330"/>
-          </a:xfrm>
-          <a:prstGeom prst="rect">
-            <a:avLst/>
-          </a:prstGeom>
-          <a:noFill/>
-        </p:spPr>
-        <p:txBody>
-          <a:bodyPr wrap="square">
-            <a:spAutoFit/>
-          </a:bodyPr>
-          <a:lstStyle/>
-          <a:p>
-            <a:r>
-              <a:rPr lang="en-US" dirty="0"/>
+            <a:pPr lvl="3"/>
+            <a:r>
+              <a:rPr lang="en-US" sz="2000" dirty="0"/>
+              <a:t>excellent Markdown guide: </a:t>
+            </a:r>
+            <a:r>
+              <a:rPr lang="en-US" sz="2000" dirty="0">
+                <a:hlinkClick r:id="rId3"/>
+              </a:rPr>
+              <a:t>https://www.markdownguide.org/</a:t>
+            </a:r>
+            <a:endParaRPr lang="en-US" sz="2000" dirty="0"/>
+          </a:p>
+          <a:p>
+            <a:pPr lvl="3"/>
+            <a:r>
+              <a:rPr lang="en-US" sz="2000" dirty="0"/>
               <a:t>online Markdown editor:  </a:t>
             </a:r>
             <a:r>
-              <a:rPr lang="en-US" dirty="0">
+              <a:rPr lang="en-US" sz="2000" dirty="0">
                 <a:hlinkClick r:id="rId4"/>
               </a:rPr>
               <a:t>https://dillinger.io/</a:t>
             </a:r>
-            <a:br>
-              <a:rPr lang="en-US" dirty="0"/>
-            </a:br>
-            <a:r>
-              <a:rPr lang="en-US" dirty="0"/>
-              <a:t>  useful for learning and writing Markdown</a:t>
-            </a:r>
-          </a:p>
-          <a:p>
-            <a:r>
-              <a:rPr lang="en-US" dirty="0"/>
-              <a:t>   let’s take a quick look</a:t>
-            </a:r>
+            <a:r>
+              <a:rPr lang="en-US" sz="2000" dirty="0"/>
+              <a:t> -   useful for learning and writing Markdown- let’s take a quick look</a:t>
+            </a:r>
+          </a:p>
+          <a:p>
+            <a:pPr lvl="2"/>
+            <a:endParaRPr lang="en-US" sz="2200" dirty="0"/>
+          </a:p>
+          <a:p>
+            <a:pPr lvl="1"/>
+            <a:endParaRPr lang="en-US" sz="2400" dirty="0">
+              <a:hlinkClick r:id="rId5"/>
+            </a:endParaRPr>
+          </a:p>
+          <a:p>
+            <a:pPr lvl="1"/>
+            <a:endParaRPr lang="en-US" sz="2400" dirty="0"/>
           </a:p>
         </p:txBody>
       </p:sp>

</xml_diff>